<commit_message>
Add deterministic sealed-bid bargaining
</commit_message>
<xml_diff>
--- a/docs/assets/commerce-arbiter-overview.pptx
+++ b/docs/assets/commerce-arbiter-overview.pptx
@@ -2,13 +2,13 @@
 <file path=ppt/presentation.xml><?xml version="1.0" encoding="utf-8"?>
 <p:presentation xmlns:p="http://schemas.openxmlformats.org/presentationml/2006/main">
   <p:sldMasterIdLst>
-    <p:sldMasterId xmlns:r="http://schemas.openxmlformats.org/officeDocument/2006/relationships" id="2147483648" r:id="Rd42535d3cee84eff"/>
+    <p:sldMasterId xmlns:r="http://schemas.openxmlformats.org/officeDocument/2006/relationships" id="2147483648" r:id="Re72350e4dab541e1"/>
   </p:sldMasterIdLst>
   <p:notesMasterIdLst>
-    <p:notesMasterId xmlns:r="http://schemas.openxmlformats.org/officeDocument/2006/relationships" r:id="R47203dba2e854e76"/>
+    <p:notesMasterId xmlns:r="http://schemas.openxmlformats.org/officeDocument/2006/relationships" r:id="Rad881addd43b4c5e"/>
   </p:notesMasterIdLst>
   <p:sldIdLst>
-    <p:sldId xmlns:r="http://schemas.openxmlformats.org/officeDocument/2006/relationships" id="256" r:id="R79cc6be9aa514949"/>
+    <p:sldId xmlns:r="http://schemas.openxmlformats.org/officeDocument/2006/relationships" id="256" r:id="R7e7e99406da346e3"/>
   </p:sldIdLst>
   <p:sldSz cx="12192000" cy="6858000"/>
   <p:notesSz cx="6858000" cy="9144000"/>
@@ -442,7 +442,7 @@
           <a:lstStyle xmlns:a="http://schemas.openxmlformats.org/drawingml/2006/main"/>
           <a:p xmlns:a="http://schemas.openxmlformats.org/drawingml/2006/main">
             <a:r>
-              <a:t>Based on the agent-commerce-demo implementation. Direct agent-to-agent conversations remain available for discovery, but middleware replaces price claims with fixed catalogue data and a caveat. The arbiter alone issues provider-scoped capabilities, runs negotiation rounds, registers offers, and accepts owner-controlled settlement actions.</a:t>
+              <a:t>Based on the agent-commerce-demo implementation. Direct agent-to-agent conversations remain available for discovery, but middleware replaces price claims with fixed catalogue data and a caveat. Provider adapters submit sealed, salted commitments without accepting model-supplied prices. The arbiter computes the equal-weight Nash bargaining solution for linear utilities over the buyer ceiling and provider floor, or returns NO AGREEMENT when the feasible interval is empty. Owner credentials remain outside agent context and alone control settlement. Sources: John F. Nash Jr., The Bargaining Problem, Econometrica 18(2), 1950, https://www.jstor.org/stable/1907266. Roger B. Myerson and Mark A. Satterthwaite, Efficient Mechanisms for Bilateral Trading, Journal of Economic Theory 29(2), 1983, https://doi.org/10.1016/0022-0531(83)90048-0.</a:t>
             </a:r>
           </a:p>
         </p:txBody>
@@ -510,7 +510,7 @@
   </p:cSld>
   <p:clrMap bg1="lt1" tx1="dk1" bg2="lt2" tx2="dk2" accent1="accent1" accent2="accent2" accent3="accent3" accent4="accent4" accent5="accent5" accent6="accent6" hlink="hlink" folHlink="folHlink"/>
   <p:sldLayoutIdLst>
-    <p:sldLayoutId xmlns:r="http://schemas.openxmlformats.org/officeDocument/2006/relationships" id="2147483649" r:id="R65ea96e182624089"/>
+    <p:sldLayoutId xmlns:r="http://schemas.openxmlformats.org/officeDocument/2006/relationships" id="2147483649" r:id="R74d2576ca73f440b"/>
   </p:sldLayoutIdLst>
   <p:txStyles>
     <p:titleStyle>
@@ -1061,7 +1061,7 @@
           <p:cNvPr id="34" name="">
             <a:extLst xmlns:a="http://schemas.openxmlformats.org/drawingml/2006/main">
               <a:ext uri="{FF2B5EF4-FFF2-40B4-BE49-F238E27FC236}">
-                <a16:creationId xmlns:a16="http://schemas.microsoft.com/office/drawing/2014/main" id="{BD84AFB1-A61A-45F9-A346-49BC132AD7F2}"/>
+                <a16:creationId xmlns:a16="http://schemas.microsoft.com/office/drawing/2014/main" id="{D45C894F-734B-4771-8ACE-7B1B082E9999}"/>
               </a:ext>
             </a:extLst>
           </p:cNvPr>
@@ -1122,7 +1122,7 @@
           <p:cNvPr id="2" name="">
             <a:extLst xmlns:a="http://schemas.openxmlformats.org/drawingml/2006/main">
               <a:ext uri="{FF2B5EF4-FFF2-40B4-BE49-F238E27FC236}">
-                <a16:creationId xmlns:a16="http://schemas.microsoft.com/office/drawing/2014/main" id="{C729F410-80CC-45BF-B510-CA45935E5883}"/>
+                <a16:creationId xmlns:a16="http://schemas.microsoft.com/office/drawing/2014/main" id="{0F07A69B-AFAF-472D-AE90-12F2AE46D5B4}"/>
               </a:ext>
             </a:extLst>
           </p:cNvPr>
@@ -1173,7 +1173,7 @@
                 <a:ea typeface="Helvetica Neue"/>
                 <a:cs typeface="Helvetica Neue"/>
               </a:rPr>
-              <a:t>Direct A2A supports discovery. The coded arbiter controls offers and settlement.</a:t>
+              <a:t>Direct A2A supports discovery. Sealed bids let the arbiter compute a compromise—or no deal.</a:t>
             </a:r>
           </a:p>
         </p:txBody>
@@ -1183,7 +1183,7 @@
           <p:cNvPr id="3" name="">
             <a:extLst xmlns:a="http://schemas.openxmlformats.org/drawingml/2006/main">
               <a:ext uri="{FF2B5EF4-FFF2-40B4-BE49-F238E27FC236}">
-                <a16:creationId xmlns:a16="http://schemas.microsoft.com/office/drawing/2014/main" id="{630B2611-8A60-43F8-8153-2B71DCEF9168}"/>
+                <a16:creationId xmlns:a16="http://schemas.microsoft.com/office/drawing/2014/main" id="{BE7106EE-4EC1-44FE-91F9-FCB0BC355BA5}"/>
               </a:ext>
             </a:extLst>
           </p:cNvPr>
@@ -1218,7 +1218,7 @@
           <p:cNvPr id="4" name="">
             <a:extLst xmlns:a="http://schemas.openxmlformats.org/drawingml/2006/main">
               <a:ext uri="{FF2B5EF4-FFF2-40B4-BE49-F238E27FC236}">
-                <a16:creationId xmlns:a16="http://schemas.microsoft.com/office/drawing/2014/main" id="{97C89132-5D3A-4824-8FBE-5171DCB2175D}"/>
+                <a16:creationId xmlns:a16="http://schemas.microsoft.com/office/drawing/2014/main" id="{2696941B-95A4-4DE5-8F6E-79C2298D0A9B}"/>
               </a:ext>
             </a:extLst>
           </p:cNvPr>
@@ -1279,7 +1279,7 @@
           <p:cNvPr id="5" name="">
             <a:extLst xmlns:a="http://schemas.openxmlformats.org/drawingml/2006/main">
               <a:ext uri="{FF2B5EF4-FFF2-40B4-BE49-F238E27FC236}">
-                <a16:creationId xmlns:a16="http://schemas.microsoft.com/office/drawing/2014/main" id="{D030B5DF-41E5-4B3A-A5F1-964FA688767C}"/>
+                <a16:creationId xmlns:a16="http://schemas.microsoft.com/office/drawing/2014/main" id="{812C6EF5-D20C-4679-B17D-A129FEAC92F2}"/>
               </a:ext>
             </a:extLst>
           </p:cNvPr>
@@ -1367,7 +1367,7 @@
           <p:cNvPr id="6" name="">
             <a:extLst xmlns:a="http://schemas.openxmlformats.org/drawingml/2006/main">
               <a:ext uri="{FF2B5EF4-FFF2-40B4-BE49-F238E27FC236}">
-                <a16:creationId xmlns:a16="http://schemas.microsoft.com/office/drawing/2014/main" id="{9127283E-AFEA-4A77-9FB8-A75A4974F228}"/>
+                <a16:creationId xmlns:a16="http://schemas.microsoft.com/office/drawing/2014/main" id="{84E5099F-767D-4CAA-9D0C-31C2F2117766}"/>
               </a:ext>
             </a:extLst>
           </p:cNvPr>
@@ -1402,7 +1402,7 @@
           <p:cNvPr id="7" name="">
             <a:extLst xmlns:a="http://schemas.openxmlformats.org/drawingml/2006/main">
               <a:ext uri="{FF2B5EF4-FFF2-40B4-BE49-F238E27FC236}">
-                <a16:creationId xmlns:a16="http://schemas.microsoft.com/office/drawing/2014/main" id="{015E5F5A-FAC1-4C72-A05A-B8000CAECB64}"/>
+                <a16:creationId xmlns:a16="http://schemas.microsoft.com/office/drawing/2014/main" id="{A7FC8602-9D5A-4E20-9759-2F9BF1331157}"/>
               </a:ext>
             </a:extLst>
           </p:cNvPr>
@@ -1463,7 +1463,7 @@
           <p:cNvPr id="8" name="">
             <a:extLst xmlns:a="http://schemas.openxmlformats.org/drawingml/2006/main">
               <a:ext uri="{FF2B5EF4-FFF2-40B4-BE49-F238E27FC236}">
-                <a16:creationId xmlns:a16="http://schemas.microsoft.com/office/drawing/2014/main" id="{371948D6-4606-4654-A5AF-DB3191EED0F2}"/>
+                <a16:creationId xmlns:a16="http://schemas.microsoft.com/office/drawing/2014/main" id="{9D670A8C-37ED-441B-A44C-F8BD7D5DC492}"/>
               </a:ext>
             </a:extLst>
           </p:cNvPr>
@@ -1551,7 +1551,7 @@
           <p:cNvPr id="9" name="">
             <a:extLst xmlns:a="http://schemas.openxmlformats.org/drawingml/2006/main">
               <a:ext uri="{FF2B5EF4-FFF2-40B4-BE49-F238E27FC236}">
-                <a16:creationId xmlns:a16="http://schemas.microsoft.com/office/drawing/2014/main" id="{27D35F83-66F4-4EEE-927A-A2150D114F6D}"/>
+                <a16:creationId xmlns:a16="http://schemas.microsoft.com/office/drawing/2014/main" id="{542C4C21-559A-48FC-B49E-5E00A946E32B}"/>
               </a:ext>
             </a:extLst>
           </p:cNvPr>
@@ -1586,7 +1586,7 @@
           <p:cNvPr id="10" name="">
             <a:extLst xmlns:a="http://schemas.openxmlformats.org/drawingml/2006/main">
               <a:ext uri="{FF2B5EF4-FFF2-40B4-BE49-F238E27FC236}">
-                <a16:creationId xmlns:a16="http://schemas.microsoft.com/office/drawing/2014/main" id="{E37F0AF3-0382-496B-BDE4-A57BFA7FE08A}"/>
+                <a16:creationId xmlns:a16="http://schemas.microsoft.com/office/drawing/2014/main" id="{A336363B-13A9-4D72-AE6A-04C9EB306F59}"/>
               </a:ext>
             </a:extLst>
           </p:cNvPr>
@@ -1647,7 +1647,7 @@
           <p:cNvPr id="11" name="">
             <a:extLst xmlns:a="http://schemas.openxmlformats.org/drawingml/2006/main">
               <a:ext uri="{FF2B5EF4-FFF2-40B4-BE49-F238E27FC236}">
-                <a16:creationId xmlns:a16="http://schemas.microsoft.com/office/drawing/2014/main" id="{DF83C57D-C36B-4560-A756-E6892C49FF0C}"/>
+                <a16:creationId xmlns:a16="http://schemas.microsoft.com/office/drawing/2014/main" id="{8A85F69C-C582-405D-B3AA-9AA0D7836F63}"/>
               </a:ext>
             </a:extLst>
           </p:cNvPr>
@@ -1678,7 +1678,7 @@
           <p:cNvPr id="12" name="">
             <a:extLst xmlns:a="http://schemas.openxmlformats.org/drawingml/2006/main">
               <a:ext uri="{FF2B5EF4-FFF2-40B4-BE49-F238E27FC236}">
-                <a16:creationId xmlns:a16="http://schemas.microsoft.com/office/drawing/2014/main" id="{FA12924C-776A-445C-B209-C008B1DD8A21}"/>
+                <a16:creationId xmlns:a16="http://schemas.microsoft.com/office/drawing/2014/main" id="{B1245EAC-331B-4C7B-AA98-FA098B9F68C2}"/>
               </a:ext>
             </a:extLst>
           </p:cNvPr>
@@ -1689,8 +1689,8 @@
         </p:nvSpPr>
         <p:spPr>
           <a:xfrm xmlns:a="http://schemas.openxmlformats.org/drawingml/2006/main">
-            <a:off x="4829175" y="3076575"/>
-            <a:ext cx="2533650" cy="342900"/>
+            <a:off x="4743450" y="3076575"/>
+            <a:ext cx="2705100" cy="400050"/>
           </a:xfrm>
           <a:prstGeom xmlns:a="http://schemas.openxmlformats.org/drawingml/2006/main" prst="rect">
             <a:avLst/>
@@ -1711,7 +1711,7 @@
                 <a:spcPct val="100000"/>
               </a:lnSpc>
               <a:buNone/>
-              <a:defRPr sz="1575" b="0">
+              <a:defRPr sz="1500" b="0">
                 <a:solidFill>
                   <a:srgbClr val="172019"/>
                 </a:solidFill>
@@ -1721,7 +1721,7 @@
               </a:defRPr>
             </a:pPr>
             <a:r>
-              <a:rPr sz="1575" b="0">
+              <a:rPr sz="1500" b="0">
                 <a:solidFill>
                   <a:srgbClr val="172019"/>
                 </a:solidFill>
@@ -1729,7 +1729,7 @@
                 <a:ea typeface="Helvetica Neue"/>
                 <a:cs typeface="Helvetica Neue"/>
               </a:rPr>
-              <a:t>Keeps the mandate and budget private</a:t>
+              <a:t>Keeps raw values out of agent messages</a:t>
             </a:r>
           </a:p>
         </p:txBody>
@@ -1739,7 +1739,7 @@
           <p:cNvPr id="13" name="">
             <a:extLst xmlns:a="http://schemas.openxmlformats.org/drawingml/2006/main">
               <a:ext uri="{FF2B5EF4-FFF2-40B4-BE49-F238E27FC236}">
-                <a16:creationId xmlns:a16="http://schemas.microsoft.com/office/drawing/2014/main" id="{BAE46224-87EB-474F-B05C-FCBB45F784A8}"/>
+                <a16:creationId xmlns:a16="http://schemas.microsoft.com/office/drawing/2014/main" id="{7203BB7D-8656-4276-A9E7-CC55DF07A241}"/>
               </a:ext>
             </a:extLst>
           </p:cNvPr>
@@ -1750,8 +1750,8 @@
         </p:nvSpPr>
         <p:spPr>
           <a:xfrm xmlns:a="http://schemas.openxmlformats.org/drawingml/2006/main">
-            <a:off x="4829175" y="3505200"/>
-            <a:ext cx="2533650" cy="342900"/>
+            <a:off x="4743450" y="3505200"/>
+            <a:ext cx="2705100" cy="400050"/>
           </a:xfrm>
           <a:prstGeom xmlns:a="http://schemas.openxmlformats.org/drawingml/2006/main" prst="rect">
             <a:avLst/>
@@ -1772,7 +1772,7 @@
                 <a:spcPct val="100000"/>
               </a:lnSpc>
               <a:buNone/>
-              <a:defRPr sz="1575" b="0">
+              <a:defRPr sz="1500" b="0">
                 <a:solidFill>
                   <a:srgbClr val="172019"/>
                 </a:solidFill>
@@ -1782,7 +1782,7 @@
               </a:defRPr>
             </a:pPr>
             <a:r>
-              <a:rPr sz="1575" b="0">
+              <a:rPr sz="1500" b="0">
                 <a:solidFill>
                   <a:srgbClr val="172019"/>
                 </a:solidFill>
@@ -1790,7 +1790,7 @@
                 <a:ea typeface="Helvetica Neue"/>
                 <a:cs typeface="Helvetica Neue"/>
               </a:rPr>
-              <a:t>Runs the fixed negotiation protocol</a:t>
+              <a:t>Computes equal-weight Nash compromise</a:t>
             </a:r>
           </a:p>
         </p:txBody>
@@ -1800,7 +1800,7 @@
           <p:cNvPr id="14" name="">
             <a:extLst xmlns:a="http://schemas.openxmlformats.org/drawingml/2006/main">
               <a:ext uri="{FF2B5EF4-FFF2-40B4-BE49-F238E27FC236}">
-                <a16:creationId xmlns:a16="http://schemas.microsoft.com/office/drawing/2014/main" id="{15B1874D-05FB-49E7-80BC-89483EFA1762}"/>
+                <a16:creationId xmlns:a16="http://schemas.microsoft.com/office/drawing/2014/main" id="{2880ABEC-1566-42D6-BC50-CF733793B7A4}"/>
               </a:ext>
             </a:extLst>
           </p:cNvPr>
@@ -1811,8 +1811,8 @@
         </p:nvSpPr>
         <p:spPr>
           <a:xfrm xmlns:a="http://schemas.openxmlformats.org/drawingml/2006/main">
-            <a:off x="4829175" y="3933825"/>
-            <a:ext cx="2533650" cy="342900"/>
+            <a:off x="4743450" y="3962400"/>
+            <a:ext cx="2705100" cy="342900"/>
           </a:xfrm>
           <a:prstGeom xmlns:a="http://schemas.openxmlformats.org/drawingml/2006/main" prst="rect">
             <a:avLst/>
@@ -1833,7 +1833,7 @@
                 <a:spcPct val="100000"/>
               </a:lnSpc>
               <a:buNone/>
-              <a:defRPr sz="1575" b="0">
+              <a:defRPr sz="1500" b="0">
                 <a:solidFill>
                   <a:srgbClr val="172019"/>
                 </a:solidFill>
@@ -1843,7 +1843,7 @@
               </a:defRPr>
             </a:pPr>
             <a:r>
-              <a:rPr sz="1575" b="0">
+              <a:rPr sz="1500" b="0">
                 <a:solidFill>
                   <a:srgbClr val="172019"/>
                 </a:solidFill>
@@ -1851,7 +1851,7 @@
                 <a:ea typeface="Helvetica Neue"/>
                 <a:cs typeface="Helvetica Neue"/>
               </a:rPr>
-              <a:t>Registers immutable offers</a:t>
+              <a:t>Registers an offer or NO AGREEMENT</a:t>
             </a:r>
           </a:p>
         </p:txBody>
@@ -1861,7 +1861,7 @@
           <p:cNvPr id="15" name="">
             <a:extLst xmlns:a="http://schemas.openxmlformats.org/drawingml/2006/main">
               <a:ext uri="{FF2B5EF4-FFF2-40B4-BE49-F238E27FC236}">
-                <a16:creationId xmlns:a16="http://schemas.microsoft.com/office/drawing/2014/main" id="{F8396AFE-599B-4634-BC3B-2B822A74F311}"/>
+                <a16:creationId xmlns:a16="http://schemas.microsoft.com/office/drawing/2014/main" id="{5F00768E-5E35-4C21-B34D-B9AA3A798337}"/>
               </a:ext>
             </a:extLst>
           </p:cNvPr>
@@ -1922,7 +1922,7 @@
           <p:cNvPr id="16" name="">
             <a:extLst xmlns:a="http://schemas.openxmlformats.org/drawingml/2006/main">
               <a:ext uri="{FF2B5EF4-FFF2-40B4-BE49-F238E27FC236}">
-                <a16:creationId xmlns:a16="http://schemas.microsoft.com/office/drawing/2014/main" id="{C8B0ECA3-EED0-403A-82A4-21ABD6A477EF}"/>
+                <a16:creationId xmlns:a16="http://schemas.microsoft.com/office/drawing/2014/main" id="{80E0E026-0C9F-4F13-9BE5-FA0E9EFE7857}"/>
               </a:ext>
             </a:extLst>
           </p:cNvPr>
@@ -1954,7 +1954,7 @@
           <p:cNvPr id="17" name="">
             <a:extLst xmlns:a="http://schemas.openxmlformats.org/drawingml/2006/main">
               <a:ext uri="{FF2B5EF4-FFF2-40B4-BE49-F238E27FC236}">
-                <a16:creationId xmlns:a16="http://schemas.microsoft.com/office/drawing/2014/main" id="{80BEAD3D-31CC-43B5-A53A-033FADE449FF}"/>
+                <a16:creationId xmlns:a16="http://schemas.microsoft.com/office/drawing/2014/main" id="{457E3B60-4C26-4540-9CD3-0A68E96A570C}"/>
               </a:ext>
             </a:extLst>
           </p:cNvPr>
@@ -2013,7 +2013,7 @@
           <p:cNvPr id="19" name="">
             <a:extLst xmlns:a="http://schemas.openxmlformats.org/drawingml/2006/main">
               <a:ext uri="{FF2B5EF4-FFF2-40B4-BE49-F238E27FC236}">
-                <a16:creationId xmlns:a16="http://schemas.microsoft.com/office/drawing/2014/main" id="{05632C05-4370-4978-BD4F-BE12DE32F173}"/>
+                <a16:creationId xmlns:a16="http://schemas.microsoft.com/office/drawing/2014/main" id="{75893842-4DA9-448C-AD8F-6C32F23613D9}"/>
               </a:ext>
             </a:extLst>
           </p:cNvPr>
@@ -2074,7 +2074,7 @@
           <p:cNvPr id="20" name="">
             <a:extLst xmlns:a="http://schemas.openxmlformats.org/drawingml/2006/main">
               <a:ext uri="{FF2B5EF4-FFF2-40B4-BE49-F238E27FC236}">
-                <a16:creationId xmlns:a16="http://schemas.microsoft.com/office/drawing/2014/main" id="{6C3DC301-49A6-47F8-A77C-670655858588}"/>
+                <a16:creationId xmlns:a16="http://schemas.microsoft.com/office/drawing/2014/main" id="{9BD15F00-05BB-4A38-B2DF-99679DB0BAE9}"/>
               </a:ext>
             </a:extLst>
           </p:cNvPr>
@@ -2162,7 +2162,7 @@
           <p:cNvPr id="22" name="">
             <a:extLst xmlns:a="http://schemas.openxmlformats.org/drawingml/2006/main">
               <a:ext uri="{FF2B5EF4-FFF2-40B4-BE49-F238E27FC236}">
-                <a16:creationId xmlns:a16="http://schemas.microsoft.com/office/drawing/2014/main" id="{530F5D02-4C30-4404-AC98-C479088D1716}"/>
+                <a16:creationId xmlns:a16="http://schemas.microsoft.com/office/drawing/2014/main" id="{DE212D9D-9327-4D0F-8AB2-950007F08A0A}"/>
               </a:ext>
             </a:extLst>
           </p:cNvPr>
@@ -2223,7 +2223,7 @@
           <p:cNvPr id="23" name="">
             <a:extLst xmlns:a="http://schemas.openxmlformats.org/drawingml/2006/main">
               <a:ext uri="{FF2B5EF4-FFF2-40B4-BE49-F238E27FC236}">
-                <a16:creationId xmlns:a16="http://schemas.microsoft.com/office/drawing/2014/main" id="{86389FD2-6C7E-453E-BC68-AF0832C87532}"/>
+                <a16:creationId xmlns:a16="http://schemas.microsoft.com/office/drawing/2014/main" id="{CE1C3225-37D3-4921-8C39-B004CC08487F}"/>
               </a:ext>
             </a:extLst>
           </p:cNvPr>
@@ -2234,8 +2234,96 @@
         </p:nvSpPr>
         <p:spPr>
           <a:xfrm xmlns:a="http://schemas.openxmlformats.org/drawingml/2006/main">
-            <a:off x="3048000" y="3895725"/>
-            <a:ext cx="1390650" cy="238125"/>
+            <a:off x="3009900" y="3895725"/>
+            <a:ext cx="1466850" cy="238125"/>
+          </a:xfrm>
+          <a:prstGeom xmlns:a="http://schemas.openxmlformats.org/drawingml/2006/main" prst="rect">
+            <a:avLst/>
+          </a:prstGeom>
+          <a:noFill xmlns:a="http://schemas.openxmlformats.org/drawingml/2006/main"/>
+          <a:ln xmlns:a="http://schemas.openxmlformats.org/drawingml/2006/main" w="0">
+            <a:noFill/>
+          </a:ln>
+        </p:spPr>
+        <p:txBody>
+          <a:bodyPr xmlns:a="http://schemas.openxmlformats.org/drawingml/2006/main" wrap="square" lIns="0" tIns="0" rIns="0" bIns="0" anchor="t">
+            <a:noAutofit/>
+          </a:bodyPr>
+          <a:lstStyle xmlns:a="http://schemas.openxmlformats.org/drawingml/2006/main"/>
+          <a:p xmlns:a="http://schemas.openxmlformats.org/drawingml/2006/main">
+            <a:pPr algn="ctr">
+              <a:lnSpc>
+                <a:spcPct val="100000"/>
+              </a:lnSpc>
+              <a:buNone/>
+              <a:defRPr sz="1275" b="1">
+                <a:solidFill>
+                  <a:srgbClr val="4A6FE3"/>
+                </a:solidFill>
+                <a:latin typeface="Helvetica Neue"/>
+                <a:ea typeface="Helvetica Neue"/>
+                <a:cs typeface="Helvetica Neue"/>
+              </a:defRPr>
+            </a:pPr>
+            <a:r>
+              <a:rPr sz="1275" b="1">
+                <a:solidFill>
+                  <a:srgbClr val="4A6FE3"/>
+                </a:solidFill>
+                <a:latin typeface="Helvetica Neue"/>
+                <a:ea typeface="Helvetica Neue"/>
+                <a:cs typeface="Helvetica Neue"/>
+              </a:rPr>
+              <a:t>Compromise / no deal</a:t>
+            </a:r>
+          </a:p>
+        </p:txBody>
+      </p:sp>
+      <p:cxnSp>
+        <p:nvCxnSpPr>
+          <p:cNvPr id="57" name=""/>
+          <p:cNvCxnSpPr>
+            <a:stCxn xmlns:a="http://schemas.openxmlformats.org/drawingml/2006/main" id="9" idx="3"/>
+            <a:endCxn xmlns:a="http://schemas.openxmlformats.org/drawingml/2006/main" id="6" idx="1"/>
+          </p:cNvCxnSpPr>
+          <p:nvPr/>
+        </p:nvCxnSpPr>
+        <p:spPr>
+          <a:xfrm xmlns:a="http://schemas.openxmlformats.org/drawingml/2006/main" flipV="1">
+            <a:off x="7696200" y="3552825"/>
+            <a:ext cx="1485900" cy="66675"/>
+          </a:xfrm>
+          <a:prstGeom xmlns:a="http://schemas.openxmlformats.org/drawingml/2006/main" prst="straightConnector1">
+            <a:avLst/>
+          </a:prstGeom>
+          <a:ln xmlns:a="http://schemas.openxmlformats.org/drawingml/2006/main" w="38100">
+            <a:solidFill>
+              <a:srgbClr val="EF765F"/>
+            </a:solidFill>
+            <a:prstDash val="solid"/>
+            <a:headEnd type="triangle" w="med" len="med"/>
+            <a:tailEnd type="triangle" w="med" len="med"/>
+          </a:ln>
+        </p:spPr>
+      </p:cxnSp>
+      <p:sp>
+        <p:nvSpPr>
+          <p:cNvPr id="25" name="">
+            <a:extLst xmlns:a="http://schemas.openxmlformats.org/drawingml/2006/main">
+              <a:ext uri="{FF2B5EF4-FFF2-40B4-BE49-F238E27FC236}">
+                <a16:creationId xmlns:a16="http://schemas.microsoft.com/office/drawing/2014/main" id="{689EC80B-1794-4C24-85ED-BBBD00049F0E}"/>
+              </a:ext>
+            </a:extLst>
+          </p:cNvPr>
+          <p:cNvSpPr>
+            <a:spLocks xmlns:a="http://schemas.openxmlformats.org/drawingml/2006/main" noGrp="1"/>
+          </p:cNvSpPr>
+          <p:nvPr/>
+        </p:nvSpPr>
+        <p:spPr>
+          <a:xfrm xmlns:a="http://schemas.openxmlformats.org/drawingml/2006/main">
+            <a:off x="7753350" y="3086100"/>
+            <a:ext cx="1371600" cy="238125"/>
           </a:xfrm>
           <a:prstGeom xmlns:a="http://schemas.openxmlformats.org/drawingml/2006/main" prst="rect">
             <a:avLst/>
@@ -2258,7 +2346,7 @@
               <a:buNone/>
               <a:defRPr sz="1350" b="1">
                 <a:solidFill>
-                  <a:srgbClr val="4A6FE3"/>
+                  <a:srgbClr val="EF765F"/>
                 </a:solidFill>
                 <a:latin typeface="Helvetica Neue"/>
                 <a:ea typeface="Helvetica Neue"/>
@@ -2268,50 +2356,23 @@
             <a:r>
               <a:rPr sz="1350" b="1">
                 <a:solidFill>
-                  <a:srgbClr val="4A6FE3"/>
+                  <a:srgbClr val="EF765F"/>
                 </a:solidFill>
                 <a:latin typeface="Helvetica Neue"/>
                 <a:ea typeface="Helvetica Neue"/>
                 <a:cs typeface="Helvetica Neue"/>
               </a:rPr>
-              <a:t>Canonical shortlist</a:t>
+              <a:t>Public request</a:t>
             </a:r>
           </a:p>
         </p:txBody>
       </p:sp>
-      <p:cxnSp>
-        <p:nvCxnSpPr>
-          <p:cNvPr id="57" name=""/>
-          <p:cNvCxnSpPr>
-            <a:stCxn xmlns:a="http://schemas.openxmlformats.org/drawingml/2006/main" id="9" idx="3"/>
-            <a:endCxn xmlns:a="http://schemas.openxmlformats.org/drawingml/2006/main" id="6" idx="1"/>
-          </p:cNvCxnSpPr>
-          <p:nvPr/>
-        </p:nvCxnSpPr>
-        <p:spPr>
-          <a:xfrm xmlns:a="http://schemas.openxmlformats.org/drawingml/2006/main" flipV="1">
-            <a:off x="7696200" y="3552825"/>
-            <a:ext cx="1485900" cy="66675"/>
-          </a:xfrm>
-          <a:prstGeom xmlns:a="http://schemas.openxmlformats.org/drawingml/2006/main" prst="straightConnector1">
-            <a:avLst/>
-          </a:prstGeom>
-          <a:ln xmlns:a="http://schemas.openxmlformats.org/drawingml/2006/main" w="38100">
-            <a:solidFill>
-              <a:srgbClr val="EF765F"/>
-            </a:solidFill>
-            <a:prstDash val="solid"/>
-            <a:headEnd type="triangle" w="med" len="med"/>
-            <a:tailEnd type="triangle" w="med" len="med"/>
-          </a:ln>
-        </p:spPr>
-      </p:cxnSp>
-      <p:sp>
-        <p:nvSpPr>
-          <p:cNvPr id="25" name="">
+      <p:sp>
+        <p:nvSpPr>
+          <p:cNvPr id="26" name="">
             <a:extLst xmlns:a="http://schemas.openxmlformats.org/drawingml/2006/main">
               <a:ext uri="{FF2B5EF4-FFF2-40B4-BE49-F238E27FC236}">
-                <a16:creationId xmlns:a16="http://schemas.microsoft.com/office/drawing/2014/main" id="{1923EA4D-6ACF-4E9F-945A-14716E662598}"/>
+                <a16:creationId xmlns:a16="http://schemas.microsoft.com/office/drawing/2014/main" id="{D532751F-091B-40C7-A193-4EDD04F20070}"/>
               </a:ext>
             </a:extLst>
           </p:cNvPr>
@@ -2322,8 +2383,8 @@
         </p:nvSpPr>
         <p:spPr>
           <a:xfrm xmlns:a="http://schemas.openxmlformats.org/drawingml/2006/main">
-            <a:off x="7753350" y="3086100"/>
-            <a:ext cx="1371600" cy="238125"/>
+            <a:off x="7734300" y="3895725"/>
+            <a:ext cx="1409700" cy="238125"/>
           </a:xfrm>
           <a:prstGeom xmlns:a="http://schemas.openxmlformats.org/drawingml/2006/main" prst="rect">
             <a:avLst/>
@@ -2362,78 +2423,17 @@
                 <a:ea typeface="Helvetica Neue"/>
                 <a:cs typeface="Helvetica Neue"/>
               </a:rPr>
-              <a:t>Public request</a:t>
+              <a:t>Sealed coded bid</a:t>
             </a:r>
           </a:p>
         </p:txBody>
       </p:sp>
       <p:sp>
         <p:nvSpPr>
-          <p:cNvPr id="26" name="">
-            <a:extLst xmlns:a="http://schemas.openxmlformats.org/drawingml/2006/main">
-              <a:ext uri="{FF2B5EF4-FFF2-40B4-BE49-F238E27FC236}">
-                <a16:creationId xmlns:a16="http://schemas.microsoft.com/office/drawing/2014/main" id="{41140C97-25D9-47CD-9270-4662CA37F054}"/>
-              </a:ext>
-            </a:extLst>
-          </p:cNvPr>
-          <p:cNvSpPr>
-            <a:spLocks xmlns:a="http://schemas.openxmlformats.org/drawingml/2006/main" noGrp="1"/>
-          </p:cNvSpPr>
-          <p:nvPr/>
-        </p:nvSpPr>
-        <p:spPr>
-          <a:xfrm xmlns:a="http://schemas.openxmlformats.org/drawingml/2006/main">
-            <a:off x="7734300" y="3895725"/>
-            <a:ext cx="1409700" cy="238125"/>
-          </a:xfrm>
-          <a:prstGeom xmlns:a="http://schemas.openxmlformats.org/drawingml/2006/main" prst="rect">
-            <a:avLst/>
-          </a:prstGeom>
-          <a:noFill xmlns:a="http://schemas.openxmlformats.org/drawingml/2006/main"/>
-          <a:ln xmlns:a="http://schemas.openxmlformats.org/drawingml/2006/main" w="0">
-            <a:noFill/>
-          </a:ln>
-        </p:spPr>
-        <p:txBody>
-          <a:bodyPr xmlns:a="http://schemas.openxmlformats.org/drawingml/2006/main" wrap="square" lIns="0" tIns="0" rIns="0" bIns="0" anchor="t">
-            <a:noAutofit/>
-          </a:bodyPr>
-          <a:lstStyle xmlns:a="http://schemas.openxmlformats.org/drawingml/2006/main"/>
-          <a:p xmlns:a="http://schemas.openxmlformats.org/drawingml/2006/main">
-            <a:pPr algn="ctr">
-              <a:lnSpc>
-                <a:spcPct val="100000"/>
-              </a:lnSpc>
-              <a:buNone/>
-              <a:defRPr sz="1350" b="1">
-                <a:solidFill>
-                  <a:srgbClr val="EF765F"/>
-                </a:solidFill>
-                <a:latin typeface="Helvetica Neue"/>
-                <a:ea typeface="Helvetica Neue"/>
-                <a:cs typeface="Helvetica Neue"/>
-              </a:defRPr>
-            </a:pPr>
-            <a:r>
-              <a:rPr sz="1350" b="1">
-                <a:solidFill>
-                  <a:srgbClr val="EF765F"/>
-                </a:solidFill>
-                <a:latin typeface="Helvetica Neue"/>
-                <a:ea typeface="Helvetica Neue"/>
-                <a:cs typeface="Helvetica Neue"/>
-              </a:rPr>
-              <a:t>Policy-coded quote</a:t>
-            </a:r>
-          </a:p>
-        </p:txBody>
-      </p:sp>
-      <p:sp>
-        <p:nvSpPr>
           <p:cNvPr id="27" name="">
             <a:extLst xmlns:a="http://schemas.openxmlformats.org/drawingml/2006/main">
               <a:ext uri="{FF2B5EF4-FFF2-40B4-BE49-F238E27FC236}">
-                <a16:creationId xmlns:a16="http://schemas.microsoft.com/office/drawing/2014/main" id="{F280E227-FAA8-4F74-B888-3BBEFA74CB2C}"/>
+                <a16:creationId xmlns:a16="http://schemas.microsoft.com/office/drawing/2014/main" id="{DABC639F-1A65-436E-9946-1AB0F79A9BC5}"/>
               </a:ext>
             </a:extLst>
           </p:cNvPr>
@@ -2465,7 +2465,7 @@
           <p:cNvPr id="28" name="">
             <a:extLst xmlns:a="http://schemas.openxmlformats.org/drawingml/2006/main">
               <a:ext uri="{FF2B5EF4-FFF2-40B4-BE49-F238E27FC236}">
-                <a16:creationId xmlns:a16="http://schemas.microsoft.com/office/drawing/2014/main" id="{093C5248-D87C-4B7E-8867-5A2256F84FE6}"/>
+                <a16:creationId xmlns:a16="http://schemas.microsoft.com/office/drawing/2014/main" id="{E4CE5930-80CF-4CAD-BC7A-8B966B2C0E2F}"/>
               </a:ext>
             </a:extLst>
           </p:cNvPr>
@@ -2526,7 +2526,7 @@
           <p:cNvPr id="29" name="">
             <a:extLst xmlns:a="http://schemas.openxmlformats.org/drawingml/2006/main">
               <a:ext uri="{FF2B5EF4-FFF2-40B4-BE49-F238E27FC236}">
-                <a16:creationId xmlns:a16="http://schemas.microsoft.com/office/drawing/2014/main" id="{6FACB110-024E-425D-8A0A-2AE74161F830}"/>
+                <a16:creationId xmlns:a16="http://schemas.microsoft.com/office/drawing/2014/main" id="{35C7561E-6C22-40D1-855A-CE7C7061A517}"/>
               </a:ext>
             </a:extLst>
           </p:cNvPr>
@@ -2577,7 +2577,7 @@
                 <a:ea typeface="Helvetica Neue"/>
                 <a:cs typeface="Helvetica Neue"/>
               </a:rPr>
-              <a:t>Model output has no transaction authority</a:t>
+              <a:t>Model output has no pricing authority</a:t>
             </a:r>
           </a:p>
         </p:txBody>
@@ -2587,7 +2587,7 @@
           <p:cNvPr id="30" name="">
             <a:extLst xmlns:a="http://schemas.openxmlformats.org/drawingml/2006/main">
               <a:ext uri="{FF2B5EF4-FFF2-40B4-BE49-F238E27FC236}">
-                <a16:creationId xmlns:a16="http://schemas.microsoft.com/office/drawing/2014/main" id="{F99F4CF5-3D03-4EA8-B281-94787F425AAB}"/>
+                <a16:creationId xmlns:a16="http://schemas.microsoft.com/office/drawing/2014/main" id="{D51FE4A7-9A96-4217-8499-FB2FE369D296}"/>
               </a:ext>
             </a:extLst>
           </p:cNvPr>
@@ -2638,7 +2638,7 @@
                 <a:ea typeface="Helvetica Neue"/>
                 <a:cs typeface="Helvetica Neue"/>
               </a:rPr>
-              <a:t>Runtime checks reject agent-supplied prices, identities, budgets and approvals.</a:t>
+              <a:t>Coded adapters supply bids. Runtime checks reject agent-supplied prices and approvals.</a:t>
             </a:r>
           </a:p>
         </p:txBody>
@@ -2648,7 +2648,7 @@
           <p:cNvPr id="31" name="">
             <a:extLst xmlns:a="http://schemas.openxmlformats.org/drawingml/2006/main">
               <a:ext uri="{FF2B5EF4-FFF2-40B4-BE49-F238E27FC236}">
-                <a16:creationId xmlns:a16="http://schemas.microsoft.com/office/drawing/2014/main" id="{A2911A58-A411-4451-A62D-A0018FFEF5FC}"/>
+                <a16:creationId xmlns:a16="http://schemas.microsoft.com/office/drawing/2014/main" id="{16CAB2A2-A088-4DF3-A339-7FF6FCF8286B}"/>
               </a:ext>
             </a:extLst>
           </p:cNvPr>
@@ -2679,7 +2679,7 @@
           <p:cNvPr id="32" name="">
             <a:extLst xmlns:a="http://schemas.openxmlformats.org/drawingml/2006/main">
               <a:ext uri="{FF2B5EF4-FFF2-40B4-BE49-F238E27FC236}">
-                <a16:creationId xmlns:a16="http://schemas.microsoft.com/office/drawing/2014/main" id="{4B249480-8D75-4168-89EC-65EB53B996D7}"/>
+                <a16:creationId xmlns:a16="http://schemas.microsoft.com/office/drawing/2014/main" id="{8FCCE2E4-3E28-48D2-914D-45382160647C}"/>
               </a:ext>
             </a:extLst>
           </p:cNvPr>
@@ -2730,7 +2730,7 @@
                 <a:ea typeface="Helvetica Neue"/>
                 <a:cs typeface="Helvetica Neue"/>
               </a:rPr>
-              <a:t>Capabilities enforce the permitted route</a:t>
+              <a:t>The bargaining rule is deterministic</a:t>
             </a:r>
           </a:p>
         </p:txBody>
@@ -2740,7 +2740,7 @@
           <p:cNvPr id="33" name="">
             <a:extLst xmlns:a="http://schemas.openxmlformats.org/drawingml/2006/main">
               <a:ext uri="{FF2B5EF4-FFF2-40B4-BE49-F238E27FC236}">
-                <a16:creationId xmlns:a16="http://schemas.microsoft.com/office/drawing/2014/main" id="{FB972F45-2777-4143-96B4-A3FD3A2C1361}"/>
+                <a16:creationId xmlns:a16="http://schemas.microsoft.com/office/drawing/2014/main" id="{4E5DF1CB-FF2D-4C53-997A-D90FB6A31061}"/>
               </a:ext>
             </a:extLst>
           </p:cNvPr>
@@ -2791,7 +2791,7 @@
                 <a:ea typeface="Helvetica Neue"/>
                 <a:cs typeface="Helvetica Neue"/>
               </a:rPr>
-              <a:t>Every call binds to one deal, provider and round. Owner credentials stay outside agent context.</a:t>
+              <a:t>Commitments bind one deal and provider. Empty feasible ranges return NO AGREEMENT.</a:t>
             </a:r>
           </a:p>
         </p:txBody>
@@ -2799,7 +2799,7 @@
     </p:spTree>
     <p:extLst>
       <p:ext uri="{BB962C8B-B14F-4D97-AF65-F5344CB8AC3E}">
-        <p14:creationId xmlns:p14="http://schemas.microsoft.com/office/powerpoint/2010/main" val="789422894"/>
+        <p14:creationId xmlns:p14="http://schemas.microsoft.com/office/powerpoint/2010/main" val="769182548"/>
       </p:ext>
     </p:extLst>
   </p:cSld>

</xml_diff>